<commit_message>
update ascat(TN,TO) loh and purity
</commit_message>
<xml_diff>
--- a/arm-level LOH and HI Distribution .pptx
+++ b/arm-level LOH and HI Distribution .pptx
@@ -5,12 +5,13 @@
     <p:sldMasterId id="2147483720" r:id="rId1"/>
   </p:sldMasterIdLst>
   <p:notesMasterIdLst>
-    <p:notesMasterId r:id="rId5"/>
+    <p:notesMasterId r:id="rId6"/>
   </p:notesMasterIdLst>
   <p:sldIdLst>
     <p:sldId id="558" r:id="rId2"/>
-    <p:sldId id="257" r:id="rId3"/>
-    <p:sldId id="559" r:id="rId4"/>
+    <p:sldId id="542" r:id="rId3"/>
+    <p:sldId id="257" r:id="rId4"/>
+    <p:sldId id="559" r:id="rId5"/>
   </p:sldIdLst>
   <p:sldSz cx="12192000" cy="6858000"/>
   <p:notesSz cx="6858000" cy="9144000"/>
@@ -210,7 +211,7 @@
           <a:p>
             <a:fld id="{D8D0E16C-45E4-456C-AF27-326375DC344F}" type="datetimeFigureOut">
               <a:rPr lang="zh-TW" altLang="en-US" smtClean="0"/>
-              <a:t>2025/11/7</a:t>
+              <a:t>2025/11/8</a:t>
             </a:fld>
             <a:endParaRPr lang="zh-TW" altLang="en-US"/>
           </a:p>
@@ -552,6 +553,107 @@
     <p:extLst>
       <p:ext uri="{BB962C8B-B14F-4D97-AF65-F5344CB8AC3E}">
         <p14:creationId xmlns:p14="http://schemas.microsoft.com/office/powerpoint/2010/main" val="1209224590"/>
+      </p:ext>
+    </p:extLst>
+  </p:cSld>
+  <p:clrMapOvr>
+    <a:masterClrMapping/>
+  </p:clrMapOvr>
+</p:notes>
+</file>
+
+<file path=ppt/notesSlides/notesSlide2.xml><?xml version="1.0" encoding="utf-8"?>
+<p:notes xmlns:a="http://schemas.openxmlformats.org/drawingml/2006/main" xmlns:r="http://schemas.openxmlformats.org/officeDocument/2006/relationships" xmlns:p="http://schemas.openxmlformats.org/presentationml/2006/main">
+  <p:cSld>
+    <p:spTree>
+      <p:nvGrpSpPr>
+        <p:cNvPr id="1" name=""/>
+        <p:cNvGrpSpPr/>
+        <p:nvPr/>
+      </p:nvGrpSpPr>
+      <p:grpSpPr>
+        <a:xfrm>
+          <a:off x="0" y="0"/>
+          <a:ext cx="0" cy="0"/>
+          <a:chOff x="0" y="0"/>
+          <a:chExt cx="0" cy="0"/>
+        </a:xfrm>
+      </p:grpSpPr>
+      <p:sp>
+        <p:nvSpPr>
+          <p:cNvPr id="2" name="投影片影像版面配置區 1"/>
+          <p:cNvSpPr>
+            <a:spLocks noGrp="1" noRot="1" noChangeAspect="1"/>
+          </p:cNvSpPr>
+          <p:nvPr>
+            <p:ph type="sldImg"/>
+          </p:nvPr>
+        </p:nvSpPr>
+        <p:spPr/>
+      </p:sp>
+      <p:sp>
+        <p:nvSpPr>
+          <p:cNvPr id="3" name="備忘稿版面配置區 2"/>
+          <p:cNvSpPr>
+            <a:spLocks noGrp="1"/>
+          </p:cNvSpPr>
+          <p:nvPr>
+            <p:ph type="body" idx="1"/>
+          </p:nvPr>
+        </p:nvSpPr>
+        <p:spPr/>
+        <p:txBody>
+          <a:bodyPr/>
+          <a:lstStyle/>
+          <a:p>
+            <a:pPr marL="0" marR="0" lvl="0" indent="0" algn="l" defTabSz="914400" rtl="0" eaLnBrk="1" fontAlgn="auto" latinLnBrk="0" hangingPunct="1">
+              <a:lnSpc>
+                <a:spcPct val="100000"/>
+              </a:lnSpc>
+              <a:spcBef>
+                <a:spcPts val="0"/>
+              </a:spcBef>
+              <a:spcAft>
+                <a:spcPts val="0"/>
+              </a:spcAft>
+              <a:buClrTx/>
+              <a:buSzTx/>
+              <a:buFontTx/>
+              <a:buNone/>
+              <a:tabLst/>
+              <a:defRPr/>
+            </a:pPr>
+            <a:endParaRPr lang="zh-TW" altLang="en-US" dirty="0"/>
+          </a:p>
+        </p:txBody>
+      </p:sp>
+      <p:sp>
+        <p:nvSpPr>
+          <p:cNvPr id="4" name="投影片編號版面配置區 3"/>
+          <p:cNvSpPr>
+            <a:spLocks noGrp="1"/>
+          </p:cNvSpPr>
+          <p:nvPr>
+            <p:ph type="sldNum" sz="quarter" idx="5"/>
+          </p:nvPr>
+        </p:nvSpPr>
+        <p:spPr/>
+        <p:txBody>
+          <a:bodyPr/>
+          <a:lstStyle/>
+          <a:p>
+            <a:fld id="{2F894676-250F-43B2-B5E9-FF14008517EC}" type="slidenum">
+              <a:rPr lang="zh-TW" altLang="en-US" smtClean="0"/>
+              <a:t>2</a:t>
+            </a:fld>
+            <a:endParaRPr lang="zh-TW" altLang="en-US"/>
+          </a:p>
+        </p:txBody>
+      </p:sp>
+    </p:spTree>
+    <p:extLst>
+      <p:ext uri="{BB962C8B-B14F-4D97-AF65-F5344CB8AC3E}">
+        <p14:creationId xmlns:p14="http://schemas.microsoft.com/office/powerpoint/2010/main" val="2493041608"/>
       </p:ext>
     </p:extLst>
   </p:cSld>
@@ -8854,7 +8956,7 @@
           <a:p>
             <a:fld id="{2F80B52F-6EB5-4C77-8A1E-AFDBD4E3DC24}" type="datetimeFigureOut">
               <a:rPr lang="zh-TW" altLang="en-US" smtClean="0"/>
-              <a:t>2025/11/7</a:t>
+              <a:t>2025/11/8</a:t>
             </a:fld>
             <a:endParaRPr lang="zh-TW" altLang="en-US"/>
           </a:p>
@@ -16220,6 +16322,288 @@
 </p:sldLayout>
 </file>
 
+<file path=ppt/slideLayouts/slideLayout14.xml><?xml version="1.0" encoding="utf-8"?>
+<p:sldLayout xmlns:a="http://schemas.openxmlformats.org/drawingml/2006/main" xmlns:r="http://schemas.openxmlformats.org/officeDocument/2006/relationships" xmlns:p="http://schemas.openxmlformats.org/presentationml/2006/main" userDrawn="1">
+  <p:cSld name="7_全版">
+    <p:spTree>
+      <p:nvGrpSpPr>
+        <p:cNvPr id="1" name=""/>
+        <p:cNvGrpSpPr/>
+        <p:nvPr/>
+      </p:nvGrpSpPr>
+      <p:grpSpPr>
+        <a:xfrm>
+          <a:off x="0" y="0"/>
+          <a:ext cx="0" cy="0"/>
+          <a:chOff x="0" y="0"/>
+          <a:chExt cx="0" cy="0"/>
+        </a:xfrm>
+      </p:grpSpPr>
+      <p:sp>
+        <p:nvSpPr>
+          <p:cNvPr id="6" name="內容版面配置區 15">
+            <a:extLst>
+              <a:ext uri="{FF2B5EF4-FFF2-40B4-BE49-F238E27FC236}">
+                <a16:creationId xmlns:a16="http://schemas.microsoft.com/office/drawing/2014/main" id="{2612F2B5-774A-43CF-91C4-261D5609AE7A}"/>
+              </a:ext>
+            </a:extLst>
+          </p:cNvPr>
+          <p:cNvSpPr>
+            <a:spLocks noGrp="1"/>
+          </p:cNvSpPr>
+          <p:nvPr>
+            <p:ph sz="quarter" idx="13"/>
+          </p:nvPr>
+        </p:nvSpPr>
+        <p:spPr>
+          <a:xfrm>
+            <a:off x="0" y="976631"/>
+            <a:ext cx="12192000" cy="5235996"/>
+          </a:xfrm>
+          <a:prstGeom prst="rect">
+            <a:avLst/>
+          </a:prstGeom>
+        </p:spPr>
+        <p:txBody>
+          <a:bodyPr/>
+          <a:lstStyle>
+            <a:lvl1pPr marL="0" indent="0">
+              <a:buNone/>
+              <a:defRPr/>
+            </a:lvl1pPr>
+            <a:lvl2pPr marL="457200" indent="0">
+              <a:buNone/>
+              <a:defRPr/>
+            </a:lvl2pPr>
+            <a:lvl3pPr marL="914400" indent="0">
+              <a:buNone/>
+              <a:defRPr/>
+            </a:lvl3pPr>
+            <a:lvl4pPr marL="1371600" indent="0">
+              <a:buNone/>
+              <a:defRPr/>
+            </a:lvl4pPr>
+            <a:lvl5pPr marL="1828800" indent="0">
+              <a:buNone/>
+              <a:defRPr/>
+            </a:lvl5pPr>
+          </a:lstStyle>
+          <a:p>
+            <a:pPr lvl="0"/>
+            <a:r>
+              <a:rPr lang="zh-TW" altLang="en-US" dirty="0"/>
+              <a:t>按一下以編輯母片文字樣式</a:t>
+            </a:r>
+          </a:p>
+          <a:p>
+            <a:pPr lvl="1"/>
+            <a:r>
+              <a:rPr lang="zh-TW" altLang="en-US" dirty="0"/>
+              <a:t>第二層</a:t>
+            </a:r>
+          </a:p>
+          <a:p>
+            <a:pPr lvl="2"/>
+            <a:r>
+              <a:rPr lang="zh-TW" altLang="en-US" dirty="0"/>
+              <a:t>第三層</a:t>
+            </a:r>
+          </a:p>
+          <a:p>
+            <a:pPr lvl="3"/>
+            <a:r>
+              <a:rPr lang="zh-TW" altLang="en-US" dirty="0"/>
+              <a:t>第四層</a:t>
+            </a:r>
+          </a:p>
+          <a:p>
+            <a:pPr lvl="4"/>
+            <a:r>
+              <a:rPr lang="zh-TW" altLang="en-US" dirty="0"/>
+              <a:t>第五層</a:t>
+            </a:r>
+          </a:p>
+        </p:txBody>
+      </p:sp>
+      <p:sp>
+        <p:nvSpPr>
+          <p:cNvPr id="14" name="標題 13">
+            <a:extLst>
+              <a:ext uri="{FF2B5EF4-FFF2-40B4-BE49-F238E27FC236}">
+                <a16:creationId xmlns:a16="http://schemas.microsoft.com/office/drawing/2014/main" id="{CB715F2B-5041-4E2A-A2D3-68D5D5AC18A9}"/>
+              </a:ext>
+            </a:extLst>
+          </p:cNvPr>
+          <p:cNvSpPr>
+            <a:spLocks noGrp="1"/>
+          </p:cNvSpPr>
+          <p:nvPr>
+            <p:ph type="title"/>
+          </p:nvPr>
+        </p:nvSpPr>
+        <p:spPr/>
+        <p:txBody>
+          <a:bodyPr/>
+          <a:lstStyle/>
+          <a:p>
+            <a:r>
+              <a:rPr lang="zh-TW" altLang="en-US"/>
+              <a:t>按一下以編輯母片標題樣式</a:t>
+            </a:r>
+            <a:endParaRPr lang="zh-TW" altLang="en-US" dirty="0"/>
+          </a:p>
+        </p:txBody>
+      </p:sp>
+      <p:sp>
+        <p:nvSpPr>
+          <p:cNvPr id="5" name="內容版面配置區 15">
+            <a:extLst>
+              <a:ext uri="{FF2B5EF4-FFF2-40B4-BE49-F238E27FC236}">
+                <a16:creationId xmlns:a16="http://schemas.microsoft.com/office/drawing/2014/main" id="{0C194D51-8703-4452-8C14-834C3B92B133}"/>
+              </a:ext>
+            </a:extLst>
+          </p:cNvPr>
+          <p:cNvSpPr>
+            <a:spLocks noGrp="1"/>
+          </p:cNvSpPr>
+          <p:nvPr>
+            <p:ph sz="quarter" idx="15"/>
+          </p:nvPr>
+        </p:nvSpPr>
+        <p:spPr>
+          <a:xfrm>
+            <a:off x="1619250" y="5550110"/>
+            <a:ext cx="8953500" cy="662517"/>
+          </a:xfrm>
+          <a:prstGeom prst="rect">
+            <a:avLst/>
+          </a:prstGeom>
+        </p:spPr>
+        <p:txBody>
+          <a:bodyPr/>
+          <a:lstStyle>
+            <a:lvl1pPr marL="0" indent="0">
+              <a:buNone/>
+              <a:defRPr/>
+            </a:lvl1pPr>
+            <a:lvl2pPr marL="457200" indent="0">
+              <a:buNone/>
+              <a:defRPr/>
+            </a:lvl2pPr>
+            <a:lvl3pPr marL="914400" indent="0">
+              <a:buNone/>
+              <a:defRPr/>
+            </a:lvl3pPr>
+            <a:lvl4pPr marL="1371600" indent="0">
+              <a:buNone/>
+              <a:defRPr/>
+            </a:lvl4pPr>
+            <a:lvl5pPr marL="1828800" indent="0">
+              <a:buNone/>
+              <a:defRPr/>
+            </a:lvl5pPr>
+          </a:lstStyle>
+          <a:p>
+            <a:pPr lvl="0"/>
+            <a:r>
+              <a:rPr lang="zh-TW" altLang="en-US" dirty="0"/>
+              <a:t>按一下以編輯母片文字樣式</a:t>
+            </a:r>
+          </a:p>
+        </p:txBody>
+      </p:sp>
+      <p:sp>
+        <p:nvSpPr>
+          <p:cNvPr id="2" name="日期版面配置區 1">
+            <a:extLst>
+              <a:ext uri="{FF2B5EF4-FFF2-40B4-BE49-F238E27FC236}">
+                <a16:creationId xmlns:a16="http://schemas.microsoft.com/office/drawing/2014/main" id="{A72642B5-FDB3-4766-83D2-A796D6D754AA}"/>
+              </a:ext>
+            </a:extLst>
+          </p:cNvPr>
+          <p:cNvSpPr>
+            <a:spLocks noGrp="1"/>
+          </p:cNvSpPr>
+          <p:nvPr>
+            <p:ph type="dt" sz="half" idx="16"/>
+          </p:nvPr>
+        </p:nvSpPr>
+        <p:spPr/>
+        <p:txBody>
+          <a:bodyPr/>
+          <a:lstStyle/>
+          <a:p>
+            <a:endParaRPr lang="zh-TW" altLang="en-US"/>
+          </a:p>
+        </p:txBody>
+      </p:sp>
+      <p:sp>
+        <p:nvSpPr>
+          <p:cNvPr id="3" name="頁尾版面配置區 2">
+            <a:extLst>
+              <a:ext uri="{FF2B5EF4-FFF2-40B4-BE49-F238E27FC236}">
+                <a16:creationId xmlns:a16="http://schemas.microsoft.com/office/drawing/2014/main" id="{52FD5909-B16F-4508-956D-5EDD5CF39327}"/>
+              </a:ext>
+            </a:extLst>
+          </p:cNvPr>
+          <p:cNvSpPr>
+            <a:spLocks noGrp="1"/>
+          </p:cNvSpPr>
+          <p:nvPr>
+            <p:ph type="ftr" sz="quarter" idx="17"/>
+          </p:nvPr>
+        </p:nvSpPr>
+        <p:spPr/>
+        <p:txBody>
+          <a:bodyPr/>
+          <a:lstStyle/>
+          <a:p>
+            <a:endParaRPr lang="zh-TW" altLang="en-US"/>
+          </a:p>
+        </p:txBody>
+      </p:sp>
+      <p:sp>
+        <p:nvSpPr>
+          <p:cNvPr id="4" name="投影片編號版面配置區 3">
+            <a:extLst>
+              <a:ext uri="{FF2B5EF4-FFF2-40B4-BE49-F238E27FC236}">
+                <a16:creationId xmlns:a16="http://schemas.microsoft.com/office/drawing/2014/main" id="{BE659856-424C-42C5-A70D-41730022F8EB}"/>
+              </a:ext>
+            </a:extLst>
+          </p:cNvPr>
+          <p:cNvSpPr>
+            <a:spLocks noGrp="1"/>
+          </p:cNvSpPr>
+          <p:nvPr>
+            <p:ph type="sldNum" sz="quarter" idx="18"/>
+          </p:nvPr>
+        </p:nvSpPr>
+        <p:spPr/>
+        <p:txBody>
+          <a:bodyPr/>
+          <a:lstStyle/>
+          <a:p>
+            <a:fld id="{43193797-CD42-4ACC-A583-F445B134D2AE}" type="slidenum">
+              <a:rPr lang="zh-TW" altLang="en-US" smtClean="0"/>
+              <a:t>‹#›</a:t>
+            </a:fld>
+            <a:endParaRPr lang="zh-TW" altLang="en-US"/>
+          </a:p>
+        </p:txBody>
+      </p:sp>
+    </p:spTree>
+    <p:extLst>
+      <p:ext uri="{BB962C8B-B14F-4D97-AF65-F5344CB8AC3E}">
+        <p14:creationId xmlns:p14="http://schemas.microsoft.com/office/powerpoint/2010/main" val="3157481415"/>
+      </p:ext>
+    </p:extLst>
+  </p:cSld>
+  <p:clrMapOvr>
+    <a:masterClrMapping/>
+  </p:clrMapOvr>
+</p:sldLayout>
+</file>
+
 <file path=ppt/slideLayouts/slideLayout2.xml><?xml version="1.0" encoding="utf-8"?>
 <p:sldLayout xmlns:a="http://schemas.openxmlformats.org/drawingml/2006/main" xmlns:r="http://schemas.openxmlformats.org/officeDocument/2006/relationships" xmlns:p="http://schemas.openxmlformats.org/presentationml/2006/main" preserve="1">
   <p:cSld name="1_全版">
@@ -18658,7 +19042,7 @@
           <a:p>
             <a:fld id="{2F80B52F-6EB5-4C77-8A1E-AFDBD4E3DC24}" type="datetimeFigureOut">
               <a:rPr lang="zh-TW" altLang="en-US" smtClean="0"/>
-              <a:t>2025/11/7</a:t>
+              <a:t>2025/11/8</a:t>
             </a:fld>
             <a:endParaRPr lang="zh-TW" altLang="en-US"/>
           </a:p>
@@ -18843,6 +19227,7 @@
     <p:sldLayoutId id="2147483730" r:id="rId11"/>
     <p:sldLayoutId id="2147483731" r:id="rId12"/>
     <p:sldLayoutId id="2147483732" r:id="rId13"/>
+    <p:sldLayoutId id="2147483734" r:id="rId14"/>
   </p:sldLayoutIdLst>
   <p:txStyles>
     <p:titleStyle>
@@ -19425,6 +19810,141 @@
           <a:chExt cx="0" cy="0"/>
         </a:xfrm>
       </p:grpSpPr>
+      <p:pic>
+        <p:nvPicPr>
+          <p:cNvPr id="17" name="內容版面配置區 16">
+            <a:extLst>
+              <a:ext uri="{FF2B5EF4-FFF2-40B4-BE49-F238E27FC236}">
+                <a16:creationId xmlns:a16="http://schemas.microsoft.com/office/drawing/2014/main" id="{74A87BD8-52EB-4287-B625-44E8E1836E66}"/>
+              </a:ext>
+            </a:extLst>
+          </p:cNvPr>
+          <p:cNvPicPr>
+            <a:picLocks noGrp="1" noChangeAspect="1"/>
+          </p:cNvPicPr>
+          <p:nvPr>
+            <p:ph sz="quarter" idx="13"/>
+          </p:nvPr>
+        </p:nvPicPr>
+        <p:blipFill>
+          <a:blip r:embed="rId3">
+            <a:extLst>
+              <a:ext uri="{28A0092B-C50C-407E-A947-70E740481C1C}">
+                <a14:useLocalDpi xmlns:a14="http://schemas.microsoft.com/office/drawing/2010/main" val="0"/>
+              </a:ext>
+            </a:extLst>
+          </a:blip>
+          <a:srcRect/>
+          <a:stretch/>
+        </p:blipFill>
+        <p:spPr>
+          <a:xfrm>
+            <a:off x="157850" y="976313"/>
+            <a:ext cx="11876299" cy="5235574"/>
+          </a:xfrm>
+        </p:spPr>
+      </p:pic>
+      <p:sp>
+        <p:nvSpPr>
+          <p:cNvPr id="2" name="標題 1">
+            <a:extLst>
+              <a:ext uri="{FF2B5EF4-FFF2-40B4-BE49-F238E27FC236}">
+                <a16:creationId xmlns:a16="http://schemas.microsoft.com/office/drawing/2014/main" id="{D8139A26-9AF2-4453-AAAF-CF35D7D67594}"/>
+              </a:ext>
+            </a:extLst>
+          </p:cNvPr>
+          <p:cNvSpPr>
+            <a:spLocks noGrp="1"/>
+          </p:cNvSpPr>
+          <p:nvPr>
+            <p:ph type="title"/>
+          </p:nvPr>
+        </p:nvSpPr>
+        <p:spPr/>
+        <p:txBody>
+          <a:bodyPr vert="horz" lIns="91440" tIns="45720" rIns="91440" bIns="45720" rtlCol="0" anchor="ctr">
+            <a:normAutofit/>
+          </a:bodyPr>
+          <a:lstStyle/>
+          <a:p>
+            <a:r>
+              <a:rPr lang="en-US" altLang="zh-TW" dirty="0"/>
+              <a:t>Purity Comparison</a:t>
+            </a:r>
+            <a:endParaRPr lang="zh-TW" altLang="en-US" sz="1800" b="0" dirty="0">
+              <a:solidFill>
+                <a:prstClr val="black"/>
+              </a:solidFill>
+              <a:latin typeface="Calibri Light"/>
+              <a:ea typeface="微軟正黑體 Light"/>
+            </a:endParaRPr>
+          </a:p>
+        </p:txBody>
+      </p:sp>
+      <p:pic>
+        <p:nvPicPr>
+          <p:cNvPr id="20" name="內容版面配置區 19">
+            <a:extLst>
+              <a:ext uri="{FF2B5EF4-FFF2-40B4-BE49-F238E27FC236}">
+                <a16:creationId xmlns:a16="http://schemas.microsoft.com/office/drawing/2014/main" id="{E4816677-A876-44CD-97CB-6F28EEDC2171}"/>
+              </a:ext>
+            </a:extLst>
+          </p:cNvPr>
+          <p:cNvPicPr>
+            <a:picLocks noGrp="1" noChangeAspect="1"/>
+          </p:cNvPicPr>
+          <p:nvPr>
+            <p:ph sz="quarter" idx="15"/>
+          </p:nvPr>
+        </p:nvPicPr>
+        <p:blipFill>
+          <a:blip r:embed="rId4">
+            <a:extLst>
+              <a:ext uri="{28A0092B-C50C-407E-A947-70E740481C1C}">
+                <a14:useLocalDpi xmlns:a14="http://schemas.microsoft.com/office/drawing/2010/main" val="0"/>
+              </a:ext>
+            </a:extLst>
+          </a:blip>
+          <a:srcRect/>
+          <a:stretch/>
+        </p:blipFill>
+        <p:spPr>
+          <a:xfrm>
+            <a:off x="2709652" y="6248404"/>
+            <a:ext cx="6772695" cy="319082"/>
+          </a:xfrm>
+        </p:spPr>
+      </p:pic>
+    </p:spTree>
+    <p:extLst>
+      <p:ext uri="{BB962C8B-B14F-4D97-AF65-F5344CB8AC3E}">
+        <p14:creationId xmlns:p14="http://schemas.microsoft.com/office/powerpoint/2010/main" val="183196908"/>
+      </p:ext>
+    </p:extLst>
+  </p:cSld>
+  <p:clrMapOvr>
+    <a:masterClrMapping/>
+  </p:clrMapOvr>
+</p:sld>
+</file>
+
+<file path=ppt/slides/slide3.xml><?xml version="1.0" encoding="utf-8"?>
+<p:sld xmlns:a="http://schemas.openxmlformats.org/drawingml/2006/main" xmlns:r="http://schemas.openxmlformats.org/officeDocument/2006/relationships" xmlns:p="http://schemas.openxmlformats.org/presentationml/2006/main">
+  <p:cSld>
+    <p:spTree>
+      <p:nvGrpSpPr>
+        <p:cNvPr id="1" name=""/>
+        <p:cNvGrpSpPr/>
+        <p:nvPr/>
+      </p:nvGrpSpPr>
+      <p:grpSpPr>
+        <a:xfrm>
+          <a:off x="0" y="0"/>
+          <a:ext cx="0" cy="0"/>
+          <a:chOff x="0" y="0"/>
+          <a:chExt cx="0" cy="0"/>
+        </a:xfrm>
+      </p:grpSpPr>
       <p:sp>
         <p:nvSpPr>
           <p:cNvPr id="22" name="文字版面配置區 21">
@@ -20021,7 +20541,7 @@
         <p:spPr>
           <a:xfrm>
             <a:off x="0" y="735824"/>
-            <a:ext cx="11282172" cy="923330"/>
+            <a:ext cx="11282172" cy="1200329"/>
           </a:xfrm>
           <a:prstGeom prst="rect">
             <a:avLst/>
@@ -20166,6 +20686,26 @@
               <a:rPr lang="zh-TW" altLang="en-US" dirty="0"/>
               <a:t>70.416 </a:t>
             </a:r>
+            <a:endParaRPr lang="en-US" altLang="zh-TW" dirty="0"/>
+          </a:p>
+          <a:p>
+            <a:r>
+              <a:rPr lang="pt-BR" altLang="zh-TW" dirty="0"/>
+              <a:t>Ascat(Tumor</a:t>
+            </a:r>
+            <a:r>
+              <a:rPr lang="zh-TW" altLang="en-US" dirty="0"/>
+              <a:t> </a:t>
+            </a:r>
+            <a:r>
+              <a:rPr lang="en-US" altLang="zh-TW" dirty="0"/>
+              <a:t>only</a:t>
+            </a:r>
+            <a:r>
+              <a:rPr lang="pt-BR" altLang="zh-TW" dirty="0"/>
+              <a:t>)       	0.5968       	1402     	1968.966    	6.608      		40.698 </a:t>
+            </a:r>
+            <a:endParaRPr lang="zh-TW" altLang="en-US" dirty="0"/>
           </a:p>
         </p:txBody>
       </p:sp>
@@ -20381,7 +20921,7 @@
 </p:sld>
 </file>
 
-<file path=ppt/slides/slide3.xml><?xml version="1.0" encoding="utf-8"?>
+<file path=ppt/slides/slide4.xml><?xml version="1.0" encoding="utf-8"?>
 <p:sld xmlns:a="http://schemas.openxmlformats.org/drawingml/2006/main" xmlns:r="http://schemas.openxmlformats.org/officeDocument/2006/relationships" xmlns:p="http://schemas.openxmlformats.org/presentationml/2006/main">
   <p:cSld>
     <p:spTree>

</xml_diff>